<commit_message>
Fill the deck placeholders and add the submission summary
Every placeholder a judge would have seen is gone: the event line names the
Alibaba Cloud AI Hackathon Pakistan 2026, and the "replace this with a
screenshot" line on the visualisation slide is now an actual capture of the
running dashboard, pre-cropped to the slot's aspect ratio so it neither
stretches nor runs off the slide edge.

The two "[ Add focus area ]" slots are removed rather than filled. Inventing
contributions for teammates would be worse than showing none.

SUBMISSION_SUMMARY.md is the portal's project summary at 1,492 of its 1,500
characters.

Co-Authored-By: Claude Opus 5 <noreply@anthropic.com>
</commit_message>
<xml_diff>
--- a/deliverables/TwinVerse_Inspect_AI_Pitch.pptx
+++ b/deliverables/TwinVerse_Inspect_AI_Pitch.pptx
@@ -3112,7 +3112,7 @@
                 <a:ea typeface="Calibri" pitchFamily="34" charset="-122"/>
                 <a:cs typeface="Calibri" pitchFamily="34" charset="-120"/>
               </a:rPr>
-              <a:t>[ Event / Track ]   ·   [ Date ]   ·   Bano Qabil · Alkhidmat Foundation Pakistan</a:t>
+              <a:t>Alibaba Cloud AI Hackathon Pakistan 2026   ·   Bano Qabil · Alkhidmat Foundation Pakistan</a:t>
             </a:r>
             <a:endParaRPr lang="en-US" sz="1100" dirty="0"/>
           </a:p>
@@ -4694,17 +4694,6 @@
             <a:pPr algn="ctr" indent="0" marL="0">
               <a:buNone/>
             </a:pPr>
-            <a:r>
-              <a:rPr lang="en-US" sz="1150" dirty="0">
-                <a:solidFill>
-                  <a:srgbClr val="9FB0CC"/>
-                </a:solidFill>
-                <a:latin typeface="Calibri" pitchFamily="34" charset="0"/>
-                <a:ea typeface="Calibri" pitchFamily="34" charset="-122"/>
-                <a:cs typeface="Calibri" pitchFamily="34" charset="-120"/>
-              </a:rPr>
-              <a:t>[ Add focus area ]</a:t>
-            </a:r>
             <a:endParaRPr lang="en-US" sz="1150" dirty="0"/>
           </a:p>
         </p:txBody>
@@ -4913,17 +4902,6 @@
             <a:pPr algn="ctr" indent="0" marL="0">
               <a:buNone/>
             </a:pPr>
-            <a:r>
-              <a:rPr lang="en-US" sz="1150" dirty="0">
-                <a:solidFill>
-                  <a:srgbClr val="9FB0CC"/>
-                </a:solidFill>
-                <a:latin typeface="Calibri" pitchFamily="34" charset="0"/>
-                <a:ea typeface="Calibri" pitchFamily="34" charset="-122"/>
-                <a:cs typeface="Calibri" pitchFamily="34" charset="-120"/>
-              </a:rPr>
-              <a:t>[ Add focus area ]</a:t>
-            </a:r>
             <a:endParaRPr lang="en-US" sz="1150" dirty="0"/>
           </a:p>
         </p:txBody>
@@ -11250,45 +11228,30 @@
           </a:p>
         </p:txBody>
       </p:sp>
-      <p:sp>
-        <p:nvSpPr>
-          <p:cNvPr id="26" name="Text 24"/>
-          <p:cNvSpPr txBox="1"/>
-          <p:nvPr/>
-        </p:nvSpPr>
-        <p:spPr>
-          <a:xfrm>
-            <a:off x="685800" y="5715000"/>
-            <a:ext cx="10789920" cy="320040"/>
-          </a:xfrm>
-          <a:prstGeom prst="rect">
-            <a:avLst/>
-          </a:prstGeom>
-          <a:noFill/>
-          <a:ln/>
-        </p:spPr>
-        <p:txBody>
-          <a:bodyPr wrap="square" lIns="0" tIns="0" rIns="0" bIns="0" rtlCol="0" anchor="ctr"/>
-          <a:lstStyle/>
-          <a:p>
-            <a:pPr algn="ctr" indent="0" marL="0">
-              <a:buNone/>
-            </a:pPr>
-            <a:r>
-              <a:rPr lang="en-US" sz="1150" i="1" dirty="0">
-                <a:solidFill>
-                  <a:srgbClr val="64748B"/>
-                </a:solidFill>
-                <a:latin typeface="Calibri" pitchFamily="34" charset="0"/>
-                <a:ea typeface="Calibri" pitchFamily="34" charset="-122"/>
-                <a:cs typeface="Calibri" pitchFamily="34" charset="-120"/>
-              </a:rPr>
-              <a:t>[ Replace this line with a screenshot of the dashboard and the 3D viewer ]</a:t>
-            </a:r>
-            <a:endParaRPr lang="en-US" sz="1150" dirty="0"/>
-          </a:p>
-        </p:txBody>
-      </p:sp>
+      <p:pic>
+        <p:nvPicPr>
+          <p:cNvPr id="26" name="Image 0" descr="deck_dashboard.jpg">    </p:cNvPr>
+          <p:cNvPicPr>
+            <a:picLocks noChangeAspect="1"/>
+          </p:cNvPicPr>
+          <p:nvPr/>
+        </p:nvPicPr>
+        <p:blipFill>
+          <a:blip r:embed="rId1"/>
+          <a:stretch>
+            <a:fillRect/>
+          </a:stretch>
+        </p:blipFill>
+        <p:spPr>
+          <a:xfrm>
+            <a:off x="685800" y="5532120"/>
+            <a:ext cx="10789920" cy="1143000"/>
+          </a:xfrm>
+          <a:prstGeom prst="rect">
+            <a:avLst/>
+          </a:prstGeom>
+        </p:spPr>
+      </p:pic>
     </p:spTree>
   </p:cSld>
   <p:clrMapOvr>

</xml_diff>